<commit_message>
Deck updated for Mandate v2 + served directly from the site
New control-plane slide (six shipped capabilities), refreshed numbers
(~1,300 tests / nine packages), roadmap current. Footer 'Overview deck'
now downloads the .pptx straight from the site instead of GitHub's blank
blob viewer; deck copied into site/dist at build.

Co-Authored-By: Claude Fable 5 <noreply@anthropic.com>
</commit_message>
<xml_diff>
--- a/docs/AIR-DS-overview.pptx
+++ b/docs/AIR-DS-overview.pptx
@@ -15,9 +15,10 @@
     <p:sldId id="263" r:id="rId9"/>
     <p:sldId id="264" r:id="rId10"/>
     <p:sldId id="265" r:id="rId11"/>
+    <p:sldId id="266" r:id="rId12"/>
   </p:sldIdLst>
   <p:notesMasterIdLst>
-    <p:notesMasterId r:id="rId12"/>
+    <p:notesMasterId r:id="rId13"/>
   </p:notesMasterIdLst>
   <p:sldSz cx="12192000" cy="6858000"/>
   <p:notesSz cx="6858000" cy="12192000"/>
@@ -623,6 +624,94 @@
             <a:fld id="{F7021451-1387-4CA6-816F-3879F97B5CBC}" type="slidenum">
               <a:rPr lang="en-US"/>
               <a:t>10</a:t>
+            </a:fld>
+            <a:endParaRPr lang="en-US"/>
+          </a:p>
+        </p:txBody>
+      </p:sp>
+    </p:spTree>
+    <p:extLst>
+      <p:ext uri="{BB962C8B-B14F-4D97-AF65-F5344CB8AC3E}">
+        <p14:creationId xmlns:p14="http://schemas.microsoft.com/office/powerpoint/2010/main" val="1024086991"/>
+      </p:ext>
+    </p:extLst>
+  </p:cSld>
+  <p:clrMapOvr>
+    <a:masterClrMapping/>
+  </p:clrMapOvr>
+</p:notes>
+</file>
+
+<file path=ppt/notesSlides/notesSlide11.xml><?xml version="1.0" encoding="utf-8"?>
+<p:notes xmlns:a="http://schemas.openxmlformats.org/drawingml/2006/main" xmlns:r="http://schemas.openxmlformats.org/officeDocument/2006/relationships" xmlns:p="http://schemas.openxmlformats.org/presentationml/2006/main">
+  <p:cSld>
+    <p:spTree>
+      <p:nvGrpSpPr>
+        <p:cNvPr id="1" name=""/>
+        <p:cNvGrpSpPr/>
+        <p:nvPr/>
+      </p:nvGrpSpPr>
+      <p:grpSpPr>
+        <a:xfrm>
+          <a:off x="0" y="0"/>
+          <a:ext cx="0" cy="0"/>
+          <a:chOff x="0" y="0"/>
+          <a:chExt cx="0" cy="0"/>
+        </a:xfrm>
+      </p:grpSpPr>
+      <p:sp>
+        <p:nvSpPr>
+          <p:cNvPr id="2" name="Slide Image Placeholder 1"/>
+          <p:cNvSpPr>
+            <a:spLocks noGrp="1" noRot="1" noChangeAspect="1"/>
+          </p:cNvSpPr>
+          <p:nvPr>
+            <p:ph type="sldImg"/>
+          </p:nvPr>
+        </p:nvSpPr>
+        <p:spPr/>
+      </p:sp>
+      <p:sp>
+        <p:nvSpPr>
+          <p:cNvPr id="3" name="Notes Placeholder 2"/>
+          <p:cNvSpPr>
+            <a:spLocks noGrp="1"/>
+          </p:cNvSpPr>
+          <p:nvPr>
+            <p:ph type="body" idx="1"/>
+          </p:nvPr>
+        </p:nvSpPr>
+        <p:spPr/>
+        <p:txBody>
+          <a:bodyPr/>
+          <a:lstStyle/>
+          <a:p>
+            <a:r>
+              <a:rPr lang="en-US" dirty="0"/>
+              <a:t/>
+            </a:r>
+            <a:endParaRPr lang="en-US" dirty="0"/>
+          </a:p>
+        </p:txBody>
+      </p:sp>
+      <p:sp>
+        <p:nvSpPr>
+          <p:cNvPr id="4" name="Slide Number Placeholder 3"/>
+          <p:cNvSpPr>
+            <a:spLocks noGrp="1"/>
+          </p:cNvSpPr>
+          <p:nvPr>
+            <p:ph type="sldNum" sz="quarter" idx="10"/>
+          </p:nvPr>
+        </p:nvSpPr>
+        <p:spPr/>
+        <p:txBody>
+          <a:bodyPr/>
+          <a:lstStyle/>
+          <a:p>
+            <a:fld id="{F7021451-1387-4CA6-816F-3879F97B5CBC}" type="slidenum">
+              <a:rPr lang="en-US"/>
+              <a:t>11</a:t>
             </a:fld>
             <a:endParaRPr lang="en-US"/>
           </a:p>
@@ -2130,6 +2219,13 @@
 <file path=ppt/slides/slide10.xml><?xml version="1.0" encoding="utf-8"?>
 <p:sld xmlns:a="http://schemas.openxmlformats.org/drawingml/2006/main" xmlns:r="http://schemas.openxmlformats.org/officeDocument/2006/relationships" xmlns:p="http://schemas.openxmlformats.org/presentationml/2006/main">
   <p:cSld name="Slide 10">
+    <p:bg>
+      <p:bgPr>
+        <a:solidFill>
+          <a:srgbClr val="0F172A"/>
+        </a:solidFill>
+      </p:bgPr>
+    </p:bg>
     <p:spTree>
       <p:nvGrpSpPr>
         <p:cNvPr id="1" name=""/>
@@ -2171,6 +2267,778 @@
             <a:r>
               <a:rPr lang="en-US" sz="1200" b="1" spc="300" kern="0" dirty="0">
                 <a:solidFill>
+                  <a:srgbClr val="7EA5E8"/>
+                </a:solidFill>
+                <a:latin typeface="Calibri" pitchFamily="34" charset="0"/>
+                <a:ea typeface="Calibri" pitchFamily="34" charset="-122"/>
+                <a:cs typeface="Calibri" pitchFamily="34" charset="-120"/>
+              </a:rPr>
+              <a:t>BY THE NUMBERS</a:t>
+            </a:r>
+            <a:endParaRPr lang="en-US" sz="1200" dirty="0"/>
+          </a:p>
+        </p:txBody>
+      </p:sp>
+      <p:sp>
+        <p:nvSpPr>
+          <p:cNvPr id="3" name="Text 1"/>
+          <p:cNvSpPr/>
+          <p:nvPr/>
+        </p:nvSpPr>
+        <p:spPr>
+          <a:xfrm>
+            <a:off x="548640" y="384048"/>
+            <a:ext cx="11091672" cy="685800"/>
+          </a:xfrm>
+          <a:prstGeom prst="rect">
+            <a:avLst/>
+          </a:prstGeom>
+          <a:noFill/>
+          <a:ln/>
+        </p:spPr>
+        <p:txBody>
+          <a:bodyPr wrap="square" lIns="0" tIns="0" rIns="0" bIns="0" rtlCol="0" anchor="ctr"/>
+          <a:lstStyle/>
+          <a:p>
+            <a:pPr indent="0" marL="0">
+              <a:buNone/>
+            </a:pPr>
+            <a:r>
+              <a:rPr lang="en-US" sz="3300" b="1" dirty="0">
+                <a:solidFill>
+                  <a:srgbClr val="FFFFFF"/>
+                </a:solidFill>
+                <a:latin typeface="Calibri" pitchFamily="34" charset="0"/>
+                <a:ea typeface="Calibri" pitchFamily="34" charset="-122"/>
+                <a:cs typeface="Calibri" pitchFamily="34" charset="-120"/>
+              </a:rPr>
+              <a:t>The system, measured</a:t>
+            </a:r>
+            <a:endParaRPr lang="en-US" sz="3300" dirty="0"/>
+          </a:p>
+        </p:txBody>
+      </p:sp>
+      <p:sp>
+        <p:nvSpPr>
+          <p:cNvPr id="4" name="Shape 2"/>
+          <p:cNvSpPr/>
+          <p:nvPr/>
+        </p:nvSpPr>
+        <p:spPr>
+          <a:xfrm>
+            <a:off x="548640" y="1600200"/>
+            <a:ext cx="3483864" cy="1874520"/>
+          </a:xfrm>
+          <a:prstGeom prst="roundRect">
+            <a:avLst>
+              <a:gd name="adj" fmla="val 4878"/>
+            </a:avLst>
+          </a:prstGeom>
+          <a:solidFill>
+            <a:srgbClr val="1B2740"/>
+          </a:solidFill>
+          <a:ln w="12700">
+            <a:solidFill>
+              <a:srgbClr val="2C3C5E"/>
+            </a:solidFill>
+            <a:prstDash val="solid"/>
+          </a:ln>
+        </p:spPr>
+      </p:sp>
+      <p:sp>
+        <p:nvSpPr>
+          <p:cNvPr id="5" name="Text 3"/>
+          <p:cNvSpPr/>
+          <p:nvPr/>
+        </p:nvSpPr>
+        <p:spPr>
+          <a:xfrm>
+            <a:off x="731520" y="1828800"/>
+            <a:ext cx="3118104" cy="914400"/>
+          </a:xfrm>
+          <a:prstGeom prst="rect">
+            <a:avLst/>
+          </a:prstGeom>
+          <a:noFill/>
+          <a:ln/>
+        </p:spPr>
+        <p:txBody>
+          <a:bodyPr wrap="square" lIns="0" tIns="0" rIns="0" bIns="0" rtlCol="0" anchor="ctr"/>
+          <a:lstStyle/>
+          <a:p>
+            <a:pPr algn="ctr" indent="0" marL="0">
+              <a:buNone/>
+            </a:pPr>
+            <a:r>
+              <a:rPr lang="en-US" sz="4400" b="1" dirty="0">
+                <a:solidFill>
+                  <a:srgbClr val="FFFFFF"/>
+                </a:solidFill>
+                <a:latin typeface="Calibri" pitchFamily="34" charset="0"/>
+                <a:ea typeface="Calibri" pitchFamily="34" charset="-122"/>
+                <a:cs typeface="Calibri" pitchFamily="34" charset="-120"/>
+              </a:rPr>
+              <a:t>~1,300</a:t>
+            </a:r>
+            <a:endParaRPr lang="en-US" sz="4400" dirty="0"/>
+          </a:p>
+        </p:txBody>
+      </p:sp>
+      <p:sp>
+        <p:nvSpPr>
+          <p:cNvPr id="6" name="Text 4"/>
+          <p:cNvSpPr/>
+          <p:nvPr/>
+        </p:nvSpPr>
+        <p:spPr>
+          <a:xfrm>
+            <a:off x="731520" y="2788920"/>
+            <a:ext cx="3118104" cy="548640"/>
+          </a:xfrm>
+          <a:prstGeom prst="rect">
+            <a:avLst/>
+          </a:prstGeom>
+          <a:noFill/>
+          <a:ln/>
+        </p:spPr>
+        <p:txBody>
+          <a:bodyPr wrap="square" lIns="0" tIns="0" rIns="0" bIns="0" rtlCol="0" anchor="ctr"/>
+          <a:lstStyle/>
+          <a:p>
+            <a:pPr algn="ctr" indent="0" marL="0">
+              <a:buNone/>
+            </a:pPr>
+            <a:r>
+              <a:rPr lang="en-US" sz="1200" dirty="0">
+                <a:solidFill>
+                  <a:srgbClr val="9DB0CC"/>
+                </a:solidFill>
+                <a:latin typeface="Calibri" pitchFamily="34" charset="0"/>
+                <a:ea typeface="Calibri" pitchFamily="34" charset="-122"/>
+                <a:cs typeface="Calibri" pitchFamily="34" charset="-120"/>
+              </a:rPr>
+              <a:t>tests across nine packages</a:t>
+            </a:r>
+            <a:endParaRPr lang="en-US" sz="1200" dirty="0"/>
+          </a:p>
+        </p:txBody>
+      </p:sp>
+      <p:sp>
+        <p:nvSpPr>
+          <p:cNvPr id="7" name="Shape 5"/>
+          <p:cNvSpPr/>
+          <p:nvPr/>
+        </p:nvSpPr>
+        <p:spPr>
+          <a:xfrm>
+            <a:off x="4352544" y="1600200"/>
+            <a:ext cx="3483864" cy="1874520"/>
+          </a:xfrm>
+          <a:prstGeom prst="roundRect">
+            <a:avLst>
+              <a:gd name="adj" fmla="val 4878"/>
+            </a:avLst>
+          </a:prstGeom>
+          <a:solidFill>
+            <a:srgbClr val="1B2740"/>
+          </a:solidFill>
+          <a:ln w="12700">
+            <a:solidFill>
+              <a:srgbClr val="2C3C5E"/>
+            </a:solidFill>
+            <a:prstDash val="solid"/>
+          </a:ln>
+        </p:spPr>
+      </p:sp>
+      <p:sp>
+        <p:nvSpPr>
+          <p:cNvPr id="8" name="Text 6"/>
+          <p:cNvSpPr/>
+          <p:nvPr/>
+        </p:nvSpPr>
+        <p:spPr>
+          <a:xfrm>
+            <a:off x="4535424" y="1828800"/>
+            <a:ext cx="3118104" cy="914400"/>
+          </a:xfrm>
+          <a:prstGeom prst="rect">
+            <a:avLst/>
+          </a:prstGeom>
+          <a:noFill/>
+          <a:ln/>
+        </p:spPr>
+        <p:txBody>
+          <a:bodyPr wrap="square" lIns="0" tIns="0" rIns="0" bIns="0" rtlCol="0" anchor="ctr"/>
+          <a:lstStyle/>
+          <a:p>
+            <a:pPr algn="ctr" indent="0" marL="0">
+              <a:buNone/>
+            </a:pPr>
+            <a:r>
+              <a:rPr lang="en-US" sz="4400" b="1" dirty="0">
+                <a:solidFill>
+                  <a:srgbClr val="FFFFFF"/>
+                </a:solidFill>
+                <a:latin typeface="Calibri" pitchFamily="34" charset="0"/>
+                <a:ea typeface="Calibri" pitchFamily="34" charset="-122"/>
+                <a:cs typeface="Calibri" pitchFamily="34" charset="-120"/>
+              </a:rPr>
+              <a:t>232</a:t>
+            </a:r>
+            <a:endParaRPr lang="en-US" sz="4400" dirty="0"/>
+          </a:p>
+        </p:txBody>
+      </p:sp>
+      <p:sp>
+        <p:nvSpPr>
+          <p:cNvPr id="9" name="Text 7"/>
+          <p:cNvSpPr/>
+          <p:nvPr/>
+        </p:nvSpPr>
+        <p:spPr>
+          <a:xfrm>
+            <a:off x="4535424" y="2788920"/>
+            <a:ext cx="3118104" cy="548640"/>
+          </a:xfrm>
+          <a:prstGeom prst="rect">
+            <a:avLst/>
+          </a:prstGeom>
+          <a:noFill/>
+          <a:ln/>
+        </p:spPr>
+        <p:txBody>
+          <a:bodyPr wrap="square" lIns="0" tIns="0" rIns="0" bIns="0" rtlCol="0" anchor="ctr"/>
+          <a:lstStyle/>
+          <a:p>
+            <a:pPr algn="ctr" indent="0" marL="0">
+              <a:buNone/>
+            </a:pPr>
+            <a:r>
+              <a:rPr lang="en-US" sz="1200" dirty="0">
+                <a:solidFill>
+                  <a:srgbClr val="9DB0CC"/>
+                </a:solidFill>
+                <a:latin typeface="Calibri" pitchFamily="34" charset="0"/>
+                <a:ea typeface="Calibri" pitchFamily="34" charset="-122"/>
+                <a:cs typeface="Calibri" pitchFamily="34" charset="-120"/>
+              </a:rPr>
+              <a:t>public tokens · 131 themable hooks, zero dead</a:t>
+            </a:r>
+            <a:endParaRPr lang="en-US" sz="1200" dirty="0"/>
+          </a:p>
+        </p:txBody>
+      </p:sp>
+      <p:sp>
+        <p:nvSpPr>
+          <p:cNvPr id="10" name="Shape 8"/>
+          <p:cNvSpPr/>
+          <p:nvPr/>
+        </p:nvSpPr>
+        <p:spPr>
+          <a:xfrm>
+            <a:off x="8156448" y="1600200"/>
+            <a:ext cx="3483864" cy="1874520"/>
+          </a:xfrm>
+          <a:prstGeom prst="roundRect">
+            <a:avLst>
+              <a:gd name="adj" fmla="val 4878"/>
+            </a:avLst>
+          </a:prstGeom>
+          <a:solidFill>
+            <a:srgbClr val="1B2740"/>
+          </a:solidFill>
+          <a:ln w="12700">
+            <a:solidFill>
+              <a:srgbClr val="2C3C5E"/>
+            </a:solidFill>
+            <a:prstDash val="solid"/>
+          </a:ln>
+        </p:spPr>
+      </p:sp>
+      <p:sp>
+        <p:nvSpPr>
+          <p:cNvPr id="11" name="Text 9"/>
+          <p:cNvSpPr/>
+          <p:nvPr/>
+        </p:nvSpPr>
+        <p:spPr>
+          <a:xfrm>
+            <a:off x="8339328" y="1828800"/>
+            <a:ext cx="3118104" cy="914400"/>
+          </a:xfrm>
+          <a:prstGeom prst="rect">
+            <a:avLst/>
+          </a:prstGeom>
+          <a:noFill/>
+          <a:ln/>
+        </p:spPr>
+        <p:txBody>
+          <a:bodyPr wrap="square" lIns="0" tIns="0" rIns="0" bIns="0" rtlCol="0" anchor="ctr"/>
+          <a:lstStyle/>
+          <a:p>
+            <a:pPr algn="ctr" indent="0" marL="0">
+              <a:buNone/>
+            </a:pPr>
+            <a:r>
+              <a:rPr lang="en-US" sz="4400" b="1" dirty="0">
+                <a:solidFill>
+                  <a:srgbClr val="FFFFFF"/>
+                </a:solidFill>
+                <a:latin typeface="Calibri" pitchFamily="34" charset="0"/>
+                <a:ea typeface="Calibri" pitchFamily="34" charset="-122"/>
+                <a:cs typeface="Calibri" pitchFamily="34" charset="-120"/>
+              </a:rPr>
+              <a:t>97 / 0</a:t>
+            </a:r>
+            <a:endParaRPr lang="en-US" sz="4400" dirty="0"/>
+          </a:p>
+        </p:txBody>
+      </p:sp>
+      <p:sp>
+        <p:nvSpPr>
+          <p:cNvPr id="12" name="Text 10"/>
+          <p:cNvSpPr/>
+          <p:nvPr/>
+        </p:nvSpPr>
+        <p:spPr>
+          <a:xfrm>
+            <a:off x="8339328" y="2788920"/>
+            <a:ext cx="3118104" cy="548640"/>
+          </a:xfrm>
+          <a:prstGeom prst="rect">
+            <a:avLst/>
+          </a:prstGeom>
+          <a:noFill/>
+          <a:ln/>
+        </p:spPr>
+        <p:txBody>
+          <a:bodyPr wrap="square" lIns="0" tIns="0" rIns="0" bIns="0" rtlCol="0" anchor="ctr"/>
+          <a:lstStyle/>
+          <a:p>
+            <a:pPr algn="ctr" indent="0" marL="0">
+              <a:buNone/>
+            </a:pPr>
+            <a:r>
+              <a:rPr lang="en-US" sz="1200" dirty="0">
+                <a:solidFill>
+                  <a:srgbClr val="9DB0CC"/>
+                </a:solidFill>
+                <a:latin typeface="Calibri" pitchFamily="34" charset="0"/>
+                <a:ea typeface="Calibri" pitchFamily="34" charset="-122"/>
+                <a:cs typeface="Calibri" pitchFamily="34" charset="-120"/>
+              </a:rPr>
+              <a:t>stories swept by browser axe / violations</a:t>
+            </a:r>
+            <a:endParaRPr lang="en-US" sz="1200" dirty="0"/>
+          </a:p>
+        </p:txBody>
+      </p:sp>
+      <p:sp>
+        <p:nvSpPr>
+          <p:cNvPr id="13" name="Shape 11"/>
+          <p:cNvSpPr/>
+          <p:nvPr/>
+        </p:nvSpPr>
+        <p:spPr>
+          <a:xfrm>
+            <a:off x="548640" y="3749040"/>
+            <a:ext cx="3483864" cy="1874520"/>
+          </a:xfrm>
+          <a:prstGeom prst="roundRect">
+            <a:avLst>
+              <a:gd name="adj" fmla="val 4878"/>
+            </a:avLst>
+          </a:prstGeom>
+          <a:solidFill>
+            <a:srgbClr val="1B2740"/>
+          </a:solidFill>
+          <a:ln w="12700">
+            <a:solidFill>
+              <a:srgbClr val="2C3C5E"/>
+            </a:solidFill>
+            <a:prstDash val="solid"/>
+          </a:ln>
+        </p:spPr>
+      </p:sp>
+      <p:sp>
+        <p:nvSpPr>
+          <p:cNvPr id="14" name="Text 12"/>
+          <p:cNvSpPr/>
+          <p:nvPr/>
+        </p:nvSpPr>
+        <p:spPr>
+          <a:xfrm>
+            <a:off x="731520" y="3977640"/>
+            <a:ext cx="3118104" cy="914400"/>
+          </a:xfrm>
+          <a:prstGeom prst="rect">
+            <a:avLst/>
+          </a:prstGeom>
+          <a:noFill/>
+          <a:ln/>
+        </p:spPr>
+        <p:txBody>
+          <a:bodyPr wrap="square" lIns="0" tIns="0" rIns="0" bIns="0" rtlCol="0" anchor="ctr"/>
+          <a:lstStyle/>
+          <a:p>
+            <a:pPr algn="ctr" indent="0" marL="0">
+              <a:buNone/>
+            </a:pPr>
+            <a:r>
+              <a:rPr lang="en-US" sz="4400" b="1" dirty="0">
+                <a:solidFill>
+                  <a:srgbClr val="FFFFFF"/>
+                </a:solidFill>
+                <a:latin typeface="Calibri" pitchFamily="34" charset="0"/>
+                <a:ea typeface="Calibri" pitchFamily="34" charset="-122"/>
+                <a:cs typeface="Calibri" pitchFamily="34" charset="-120"/>
+              </a:rPr>
+              <a:t>21 / 21</a:t>
+            </a:r>
+            <a:endParaRPr lang="en-US" sz="4400" dirty="0"/>
+          </a:p>
+        </p:txBody>
+      </p:sp>
+      <p:sp>
+        <p:nvSpPr>
+          <p:cNvPr id="15" name="Text 13"/>
+          <p:cNvSpPr/>
+          <p:nvPr/>
+        </p:nvSpPr>
+        <p:spPr>
+          <a:xfrm>
+            <a:off x="731520" y="4937760"/>
+            <a:ext cx="3118104" cy="548640"/>
+          </a:xfrm>
+          <a:prstGeom prst="rect">
+            <a:avLst/>
+          </a:prstGeom>
+          <a:noFill/>
+          <a:ln/>
+        </p:spPr>
+        <p:txBody>
+          <a:bodyPr wrap="square" lIns="0" tIns="0" rIns="0" bIns="0" rtlCol="0" anchor="ctr"/>
+          <a:lstStyle/>
+          <a:p>
+            <a:pPr algn="ctr" indent="0" marL="0">
+              <a:buNone/>
+            </a:pPr>
+            <a:r>
+              <a:rPr lang="en-US" sz="1200" dirty="0">
+                <a:solidFill>
+                  <a:srgbClr val="9DB0CC"/>
+                </a:solidFill>
+                <a:latin typeface="Calibri" pitchFamily="34" charset="0"/>
+                <a:ea typeface="Calibri" pitchFamily="34" charset="-122"/>
+                <a:cs typeface="Calibri" pitchFamily="34" charset="-120"/>
+              </a:rPr>
+              <a:t>evals passing · critical at 1.0</a:t>
+            </a:r>
+            <a:endParaRPr lang="en-US" sz="1200" dirty="0"/>
+          </a:p>
+        </p:txBody>
+      </p:sp>
+      <p:sp>
+        <p:nvSpPr>
+          <p:cNvPr id="16" name="Shape 14"/>
+          <p:cNvSpPr/>
+          <p:nvPr/>
+        </p:nvSpPr>
+        <p:spPr>
+          <a:xfrm>
+            <a:off x="4352544" y="3749040"/>
+            <a:ext cx="3483864" cy="1874520"/>
+          </a:xfrm>
+          <a:prstGeom prst="roundRect">
+            <a:avLst>
+              <a:gd name="adj" fmla="val 4878"/>
+            </a:avLst>
+          </a:prstGeom>
+          <a:solidFill>
+            <a:srgbClr val="1B2740"/>
+          </a:solidFill>
+          <a:ln w="12700">
+            <a:solidFill>
+              <a:srgbClr val="2C3C5E"/>
+            </a:solidFill>
+            <a:prstDash val="solid"/>
+          </a:ln>
+        </p:spPr>
+      </p:sp>
+      <p:sp>
+        <p:nvSpPr>
+          <p:cNvPr id="17" name="Text 15"/>
+          <p:cNvSpPr/>
+          <p:nvPr/>
+        </p:nvSpPr>
+        <p:spPr>
+          <a:xfrm>
+            <a:off x="4535424" y="3977640"/>
+            <a:ext cx="3118104" cy="914400"/>
+          </a:xfrm>
+          <a:prstGeom prst="rect">
+            <a:avLst/>
+          </a:prstGeom>
+          <a:noFill/>
+          <a:ln/>
+        </p:spPr>
+        <p:txBody>
+          <a:bodyPr wrap="square" lIns="0" tIns="0" rIns="0" bIns="0" rtlCol="0" anchor="ctr"/>
+          <a:lstStyle/>
+          <a:p>
+            <a:pPr algn="ctr" indent="0" marL="0">
+              <a:buNone/>
+            </a:pPr>
+            <a:r>
+              <a:rPr lang="en-US" sz="4400" b="1" dirty="0">
+                <a:solidFill>
+                  <a:srgbClr val="FFFFFF"/>
+                </a:solidFill>
+                <a:latin typeface="Calibri" pitchFamily="34" charset="0"/>
+                <a:ea typeface="Calibri" pitchFamily="34" charset="-122"/>
+                <a:cs typeface="Calibri" pitchFamily="34" charset="-120"/>
+              </a:rPr>
+              <a:t>5 / 5</a:t>
+            </a:r>
+            <a:endParaRPr lang="en-US" sz="4400" dirty="0"/>
+          </a:p>
+        </p:txBody>
+      </p:sp>
+      <p:sp>
+        <p:nvSpPr>
+          <p:cNvPr id="18" name="Text 16"/>
+          <p:cNvSpPr/>
+          <p:nvPr/>
+        </p:nvSpPr>
+        <p:spPr>
+          <a:xfrm>
+            <a:off x="4535424" y="4937760"/>
+            <a:ext cx="3118104" cy="548640"/>
+          </a:xfrm>
+          <a:prstGeom prst="rect">
+            <a:avLst/>
+          </a:prstGeom>
+          <a:noFill/>
+          <a:ln/>
+        </p:spPr>
+        <p:txBody>
+          <a:bodyPr wrap="square" lIns="0" tIns="0" rIns="0" bIns="0" rtlCol="0" anchor="ctr"/>
+          <a:lstStyle/>
+          <a:p>
+            <a:pPr algn="ctr" indent="0" marL="0">
+              <a:buNone/>
+            </a:pPr>
+            <a:r>
+              <a:rPr lang="en-US" sz="1200" dirty="0">
+                <a:solidFill>
+                  <a:srgbClr val="9DB0CC"/>
+                </a:solidFill>
+                <a:latin typeface="Calibri" pitchFamily="34" charset="0"/>
+                <a:ea typeface="Calibri" pitchFamily="34" charset="-122"/>
+                <a:cs typeface="Calibri" pitchFamily="34" charset="-120"/>
+              </a:rPr>
+              <a:t>gauntlet steps green, no LLM in the gate</a:t>
+            </a:r>
+            <a:endParaRPr lang="en-US" sz="1200" dirty="0"/>
+          </a:p>
+        </p:txBody>
+      </p:sp>
+      <p:sp>
+        <p:nvSpPr>
+          <p:cNvPr id="19" name="Shape 17"/>
+          <p:cNvSpPr/>
+          <p:nvPr/>
+        </p:nvSpPr>
+        <p:spPr>
+          <a:xfrm>
+            <a:off x="8156448" y="3749040"/>
+            <a:ext cx="3483864" cy="1874520"/>
+          </a:xfrm>
+          <a:prstGeom prst="roundRect">
+            <a:avLst>
+              <a:gd name="adj" fmla="val 4878"/>
+            </a:avLst>
+          </a:prstGeom>
+          <a:solidFill>
+            <a:srgbClr val="1B2740"/>
+          </a:solidFill>
+          <a:ln w="12700">
+            <a:solidFill>
+              <a:srgbClr val="2C3C5E"/>
+            </a:solidFill>
+            <a:prstDash val="solid"/>
+          </a:ln>
+        </p:spPr>
+      </p:sp>
+      <p:sp>
+        <p:nvSpPr>
+          <p:cNvPr id="20" name="Text 18"/>
+          <p:cNvSpPr/>
+          <p:nvPr/>
+        </p:nvSpPr>
+        <p:spPr>
+          <a:xfrm>
+            <a:off x="8339328" y="3977640"/>
+            <a:ext cx="3118104" cy="914400"/>
+          </a:xfrm>
+          <a:prstGeom prst="rect">
+            <a:avLst/>
+          </a:prstGeom>
+          <a:noFill/>
+          <a:ln/>
+        </p:spPr>
+        <p:txBody>
+          <a:bodyPr wrap="square" lIns="0" tIns="0" rIns="0" bIns="0" rtlCol="0" anchor="ctr"/>
+          <a:lstStyle/>
+          <a:p>
+            <a:pPr algn="ctr" indent="0" marL="0">
+              <a:buNone/>
+            </a:pPr>
+            <a:r>
+              <a:rPr lang="en-US" sz="4400" b="1" dirty="0">
+                <a:solidFill>
+                  <a:srgbClr val="6FD8A8"/>
+                </a:solidFill>
+                <a:latin typeface="Calibri" pitchFamily="34" charset="0"/>
+                <a:ea typeface="Calibri" pitchFamily="34" charset="-122"/>
+                <a:cs typeface="Calibri" pitchFamily="34" charset="-120"/>
+              </a:rPr>
+              <a:t>260 ms</a:t>
+            </a:r>
+            <a:endParaRPr lang="en-US" sz="4400" dirty="0"/>
+          </a:p>
+        </p:txBody>
+      </p:sp>
+      <p:sp>
+        <p:nvSpPr>
+          <p:cNvPr id="21" name="Text 19"/>
+          <p:cNvSpPr/>
+          <p:nvPr/>
+        </p:nvSpPr>
+        <p:spPr>
+          <a:xfrm>
+            <a:off x="8339328" y="4937760"/>
+            <a:ext cx="3118104" cy="548640"/>
+          </a:xfrm>
+          <a:prstGeom prst="rect">
+            <a:avLst/>
+          </a:prstGeom>
+          <a:noFill/>
+          <a:ln/>
+        </p:spPr>
+        <p:txBody>
+          <a:bodyPr wrap="square" lIns="0" tIns="0" rIns="0" bIns="0" rtlCol="0" anchor="ctr"/>
+          <a:lstStyle/>
+          <a:p>
+            <a:pPr algn="ctr" indent="0" marL="0">
+              <a:buNone/>
+            </a:pPr>
+            <a:r>
+              <a:rPr lang="en-US" sz="1200" dirty="0">
+                <a:solidFill>
+                  <a:srgbClr val="9DB0CC"/>
+                </a:solidFill>
+                <a:latin typeface="Calibri" pitchFamily="34" charset="0"/>
+                <a:ea typeface="Calibri" pitchFamily="34" charset="-122"/>
+                <a:cs typeface="Calibri" pitchFamily="34" charset="-120"/>
+              </a:rPr>
+              <a:t>full customer re-theme, AI artifacts included</a:t>
+            </a:r>
+            <a:endParaRPr lang="en-US" sz="1200" dirty="0"/>
+          </a:p>
+        </p:txBody>
+      </p:sp>
+      <p:sp>
+        <p:nvSpPr>
+          <p:cNvPr id="22" name="Text 20"/>
+          <p:cNvSpPr/>
+          <p:nvPr/>
+        </p:nvSpPr>
+        <p:spPr>
+          <a:xfrm>
+            <a:off x="548640" y="6035040"/>
+            <a:ext cx="11091672" cy="411480"/>
+          </a:xfrm>
+          <a:prstGeom prst="rect">
+            <a:avLst/>
+          </a:prstGeom>
+          <a:noFill/>
+          <a:ln/>
+        </p:spPr>
+        <p:txBody>
+          <a:bodyPr wrap="square" lIns="0" tIns="0" rIns="0" bIns="0" rtlCol="0" anchor="ctr"/>
+          <a:lstStyle/>
+          <a:p>
+            <a:pPr algn="ctr" indent="0" marL="0">
+              <a:buNone/>
+            </a:pPr>
+            <a:r>
+              <a:rPr lang="en-US" sz="1500" b="1" dirty="0">
+                <a:solidFill>
+                  <a:srgbClr val="7EE0A3"/>
+                </a:solidFill>
+                <a:latin typeface="Calibri" pitchFamily="34" charset="0"/>
+                <a:ea typeface="Calibri" pitchFamily="34" charset="-122"/>
+                <a:cs typeface="Calibri" pitchFamily="34" charset="-120"/>
+              </a:rPr>
+              <a:t>Hallucination rate across every acceptance test and the build itself:  zero.</a:t>
+            </a:r>
+            <a:endParaRPr lang="en-US" sz="1500" dirty="0"/>
+          </a:p>
+        </p:txBody>
+      </p:sp>
+    </p:spTree>
+  </p:cSld>
+  <p:clrMapOvr>
+    <a:masterClrMapping/>
+  </p:clrMapOvr>
+</p:sld>
+</file>
+
+<file path=ppt/slides/slide11.xml><?xml version="1.0" encoding="utf-8"?>
+<p:sld xmlns:a="http://schemas.openxmlformats.org/drawingml/2006/main" xmlns:r="http://schemas.openxmlformats.org/officeDocument/2006/relationships" xmlns:p="http://schemas.openxmlformats.org/presentationml/2006/main">
+  <p:cSld name="Slide 11">
+    <p:spTree>
+      <p:nvGrpSpPr>
+        <p:cNvPr id="1" name=""/>
+        <p:cNvGrpSpPr/>
+        <p:nvPr/>
+      </p:nvGrpSpPr>
+      <p:grpSpPr>
+        <a:xfrm>
+          <a:off x="0" y="0"/>
+          <a:ext cx="0" cy="0"/>
+          <a:chOff x="0" y="0"/>
+          <a:chExt cx="0" cy="0"/>
+        </a:xfrm>
+      </p:grpSpPr>
+      <p:sp>
+        <p:nvSpPr>
+          <p:cNvPr id="2" name="Text 0"/>
+          <p:cNvSpPr/>
+          <p:nvPr/>
+        </p:nvSpPr>
+        <p:spPr>
+          <a:xfrm>
+            <a:off x="548640" y="146304"/>
+            <a:ext cx="11091672" cy="274320"/>
+          </a:xfrm>
+          <a:prstGeom prst="rect">
+            <a:avLst/>
+          </a:prstGeom>
+          <a:noFill/>
+          <a:ln/>
+        </p:spPr>
+        <p:txBody>
+          <a:bodyPr wrap="square" lIns="0" tIns="0" rIns="0" bIns="0" rtlCol="0" anchor="ctr"/>
+          <a:lstStyle/>
+          <a:p>
+            <a:pPr indent="0" marL="0">
+              <a:buNone/>
+            </a:pPr>
+            <a:r>
+              <a:rPr lang="en-US" sz="1200" b="1" spc="300" kern="0" dirty="0">
+                <a:solidFill>
                   <a:srgbClr val="2563EB"/>
                 </a:solidFill>
                 <a:latin typeface="Calibri" pitchFamily="34" charset="0"/>
@@ -2582,7 +3450,7 @@
                 <a:ea typeface="Calibri" pitchFamily="34" charset="-122"/>
                 <a:cs typeface="Calibri" pitchFamily="34" charset="-120"/>
               </a:rPr>
-              <a:t>Fourteen tracked findings from the audits and acceptance tests (thin-dimension tokens, play-function execution, hook-request flow…) — each with an owner area, most one sprint of work.</a:t>
+              <a:t>Sixteen tracked findings from audits, acceptance tests, and live dogfooding (thin-dimension tokens, play-function execution, first-pass metric semantics…) — each with an owner area.</a:t>
             </a:r>
             <a:endParaRPr lang="en-US" sz="1150" dirty="0"/>
           </a:p>
@@ -8630,13 +9498,6 @@
 <file path=ppt/slides/slide9.xml><?xml version="1.0" encoding="utf-8"?>
 <p:sld xmlns:a="http://schemas.openxmlformats.org/drawingml/2006/main" xmlns:r="http://schemas.openxmlformats.org/officeDocument/2006/relationships" xmlns:p="http://schemas.openxmlformats.org/presentationml/2006/main">
   <p:cSld name="Slide 9">
-    <p:bg>
-      <p:bgPr>
-        <a:solidFill>
-          <a:srgbClr val="0F172A"/>
-        </a:solidFill>
-      </p:bgPr>
-    </p:bg>
     <p:spTree>
       <p:nvGrpSpPr>
         <p:cNvPr id="1" name=""/>
@@ -8678,13 +9539,13 @@
             <a:r>
               <a:rPr lang="en-US" sz="1200" b="1" spc="300" kern="0" dirty="0">
                 <a:solidFill>
-                  <a:srgbClr val="7EA5E8"/>
-                </a:solidFill>
-                <a:latin typeface="Calibri" pitchFamily="34" charset="0"/>
-                <a:ea typeface="Calibri" pitchFamily="34" charset="-122"/>
-                <a:cs typeface="Calibri" pitchFamily="34" charset="-120"/>
-              </a:rPr>
-              <a:t>BY THE NUMBERS</a:t>
+                  <a:srgbClr val="2563EB"/>
+                </a:solidFill>
+                <a:latin typeface="Calibri" pitchFamily="34" charset="0"/>
+                <a:ea typeface="Calibri" pitchFamily="34" charset="-122"/>
+                <a:cs typeface="Calibri" pitchFamily="34" charset="-120"/>
+              </a:rPr>
+              <a:t>MANDATE V2 — SHIPPED</a:t>
             </a:r>
             <a:endParaRPr lang="en-US" sz="1200" dirty="0"/>
           </a:p>
@@ -8717,13 +9578,13 @@
             <a:r>
               <a:rPr lang="en-US" sz="3300" b="1" dirty="0">
                 <a:solidFill>
-                  <a:srgbClr val="FFFFFF"/>
-                </a:solidFill>
-                <a:latin typeface="Calibri" pitchFamily="34" charset="0"/>
-                <a:ea typeface="Calibri" pitchFamily="34" charset="-122"/>
-                <a:cs typeface="Calibri" pitchFamily="34" charset="-120"/>
-              </a:rPr>
-              <a:t>The system, measured</a:t>
+                  <a:srgbClr val="0F172A"/>
+                </a:solidFill>
+                <a:latin typeface="Calibri" pitchFamily="34" charset="0"/>
+                <a:ea typeface="Calibri" pitchFamily="34" charset="-122"/>
+                <a:cs typeface="Calibri" pitchFamily="34" charset="-120"/>
+              </a:rPr>
+              <a:t>The design system is the proof. This is the product.</a:t>
             </a:r>
             <a:endParaRPr lang="en-US" sz="3300" dirty="0"/>
           </a:p>
@@ -8737,20 +9598,20 @@
         </p:nvSpPr>
         <p:spPr>
           <a:xfrm>
-            <a:off x="548640" y="1600200"/>
-            <a:ext cx="3483864" cy="1874520"/>
+            <a:off x="548640" y="1554480"/>
+            <a:ext cx="3514344" cy="2011680"/>
           </a:xfrm>
           <a:prstGeom prst="roundRect">
             <a:avLst>
-              <a:gd name="adj" fmla="val 4878"/>
+              <a:gd name="adj" fmla="val 4545"/>
             </a:avLst>
           </a:prstGeom>
           <a:solidFill>
-            <a:srgbClr val="1B2740"/>
+            <a:srgbClr val="F8FAFC"/>
           </a:solidFill>
           <a:ln w="12700">
             <a:solidFill>
-              <a:srgbClr val="2C3C5E"/>
+              <a:srgbClr val="E2E8F0"/>
             </a:solidFill>
             <a:prstDash val="solid"/>
           </a:ln>
@@ -8764,34 +9625,34 @@
         </p:nvSpPr>
         <p:spPr>
           <a:xfrm>
-            <a:off x="731520" y="1828800"/>
-            <a:ext cx="3118104" cy="914400"/>
-          </a:xfrm>
-          <a:prstGeom prst="rect">
-            <a:avLst/>
-          </a:prstGeom>
-          <a:noFill/>
-          <a:ln/>
-        </p:spPr>
-        <p:txBody>
-          <a:bodyPr wrap="square" lIns="0" tIns="0" rIns="0" bIns="0" rtlCol="0" anchor="ctr"/>
-          <a:lstStyle/>
-          <a:p>
-            <a:pPr algn="ctr" indent="0" marL="0">
-              <a:buNone/>
-            </a:pPr>
-            <a:r>
-              <a:rPr lang="en-US" sz="4400" b="1" dirty="0">
-                <a:solidFill>
-                  <a:srgbClr val="FFFFFF"/>
-                </a:solidFill>
-                <a:latin typeface="Calibri" pitchFamily="34" charset="0"/>
-                <a:ea typeface="Calibri" pitchFamily="34" charset="-122"/>
-                <a:cs typeface="Calibri" pitchFamily="34" charset="-120"/>
-              </a:rPr>
-              <a:t>662</a:t>
-            </a:r>
-            <a:endParaRPr lang="en-US" sz="4400" dirty="0"/>
+            <a:off x="749808" y="1700784"/>
+            <a:ext cx="3112008" cy="320040"/>
+          </a:xfrm>
+          <a:prstGeom prst="rect">
+            <a:avLst/>
+          </a:prstGeom>
+          <a:noFill/>
+          <a:ln/>
+        </p:spPr>
+        <p:txBody>
+          <a:bodyPr wrap="square" lIns="0" tIns="0" rIns="0" bIns="0" rtlCol="0" anchor="ctr"/>
+          <a:lstStyle/>
+          <a:p>
+            <a:pPr indent="0" marL="0">
+              <a:buNone/>
+            </a:pPr>
+            <a:r>
+              <a:rPr lang="en-US" sz="1300" b="1" dirty="0">
+                <a:solidFill>
+                  <a:srgbClr val="2563EB"/>
+                </a:solidFill>
+                <a:latin typeface="Courier New" pitchFamily="34" charset="0"/>
+                <a:ea typeface="Courier New" pitchFamily="34" charset="-122"/>
+                <a:cs typeface="Courier New" pitchFamily="34" charset="-120"/>
+              </a:rPr>
+              <a:t>ds-assess</a:t>
+            </a:r>
+            <a:endParaRPr lang="en-US" sz="1300" dirty="0"/>
           </a:p>
         </p:txBody>
       </p:sp>
@@ -8803,34 +9664,34 @@
         </p:nvSpPr>
         <p:spPr>
           <a:xfrm>
-            <a:off x="731520" y="2788920"/>
-            <a:ext cx="3118104" cy="548640"/>
-          </a:xfrm>
-          <a:prstGeom prst="rect">
-            <a:avLst/>
-          </a:prstGeom>
-          <a:noFill/>
-          <a:ln/>
-        </p:spPr>
-        <p:txBody>
-          <a:bodyPr wrap="square" lIns="0" tIns="0" rIns="0" bIns="0" rtlCol="0" anchor="ctr"/>
-          <a:lstStyle/>
-          <a:p>
-            <a:pPr algn="ctr" indent="0" marL="0">
-              <a:buNone/>
-            </a:pPr>
-            <a:r>
-              <a:rPr lang="en-US" sz="1200" dirty="0">
-                <a:solidFill>
-                  <a:srgbClr val="9DB0CC"/>
-                </a:solidFill>
-                <a:latin typeface="Calibri" pitchFamily="34" charset="0"/>
-                <a:ea typeface="Calibri" pitchFamily="34" charset="-122"/>
-                <a:cs typeface="Calibri" pitchFamily="34" charset="-120"/>
-              </a:rPr>
-              <a:t>tests across six packages</a:t>
-            </a:r>
-            <a:endParaRPr lang="en-US" sz="1200" dirty="0"/>
+            <a:off x="749808" y="2057400"/>
+            <a:ext cx="3112008" cy="1371600"/>
+          </a:xfrm>
+          <a:prstGeom prst="rect">
+            <a:avLst/>
+          </a:prstGeom>
+          <a:noFill/>
+          <a:ln/>
+        </p:spPr>
+        <p:txBody>
+          <a:bodyPr wrap="square" lIns="0" tIns="0" rIns="0" bIns="0" rtlCol="0" anchor="ctr"/>
+          <a:lstStyle/>
+          <a:p>
+            <a:pPr indent="0" marL="0">
+              <a:buNone/>
+            </a:pPr>
+            <a:r>
+              <a:rPr lang="en-US" sz="1100" dirty="0">
+                <a:solidFill>
+                  <a:srgbClr val="5A6B7E"/>
+                </a:solidFill>
+                <a:latin typeface="Calibri" pitchFamily="34" charset="0"/>
+                <a:ea typeface="Calibri" pitchFamily="34" charset="-122"/>
+                <a:cs typeface="Calibri" pitchFamily="34" charset="-120"/>
+              </a:rPr>
+              <a:t>Score any repo’s AI-readiness: six evidence-backed pillars. This repo: 99.4/A; a typical 2023 DS: 6.6/F, gaps named.</a:t>
+            </a:r>
+            <a:endParaRPr lang="en-US" sz="1100" dirty="0"/>
           </a:p>
         </p:txBody>
       </p:sp>
@@ -8842,20 +9703,20 @@
         </p:nvSpPr>
         <p:spPr>
           <a:xfrm>
-            <a:off x="4352544" y="1600200"/>
-            <a:ext cx="3483864" cy="1874520"/>
+            <a:off x="4337304" y="1554480"/>
+            <a:ext cx="3514344" cy="2011680"/>
           </a:xfrm>
           <a:prstGeom prst="roundRect">
             <a:avLst>
-              <a:gd name="adj" fmla="val 4878"/>
+              <a:gd name="adj" fmla="val 4545"/>
             </a:avLst>
           </a:prstGeom>
           <a:solidFill>
-            <a:srgbClr val="1B2740"/>
+            <a:srgbClr val="F8FAFC"/>
           </a:solidFill>
           <a:ln w="12700">
             <a:solidFill>
-              <a:srgbClr val="2C3C5E"/>
+              <a:srgbClr val="E2E8F0"/>
             </a:solidFill>
             <a:prstDash val="solid"/>
           </a:ln>
@@ -8869,34 +9730,34 @@
         </p:nvSpPr>
         <p:spPr>
           <a:xfrm>
-            <a:off x="4535424" y="1828800"/>
-            <a:ext cx="3118104" cy="914400"/>
-          </a:xfrm>
-          <a:prstGeom prst="rect">
-            <a:avLst/>
-          </a:prstGeom>
-          <a:noFill/>
-          <a:ln/>
-        </p:spPr>
-        <p:txBody>
-          <a:bodyPr wrap="square" lIns="0" tIns="0" rIns="0" bIns="0" rtlCol="0" anchor="ctr"/>
-          <a:lstStyle/>
-          <a:p>
-            <a:pPr algn="ctr" indent="0" marL="0">
-              <a:buNone/>
-            </a:pPr>
-            <a:r>
-              <a:rPr lang="en-US" sz="4400" b="1" dirty="0">
-                <a:solidFill>
-                  <a:srgbClr val="FFFFFF"/>
-                </a:solidFill>
-                <a:latin typeface="Calibri" pitchFamily="34" charset="0"/>
-                <a:ea typeface="Calibri" pitchFamily="34" charset="-122"/>
-                <a:cs typeface="Calibri" pitchFamily="34" charset="-120"/>
-              </a:rPr>
-              <a:t>232</a:t>
-            </a:r>
-            <a:endParaRPr lang="en-US" sz="4400" dirty="0"/>
+            <a:off x="4538472" y="1700784"/>
+            <a:ext cx="3112008" cy="320040"/>
+          </a:xfrm>
+          <a:prstGeom prst="rect">
+            <a:avLst/>
+          </a:prstGeom>
+          <a:noFill/>
+          <a:ln/>
+        </p:spPr>
+        <p:txBody>
+          <a:bodyPr wrap="square" lIns="0" tIns="0" rIns="0" bIns="0" rtlCol="0" anchor="ctr"/>
+          <a:lstStyle/>
+          <a:p>
+            <a:pPr indent="0" marL="0">
+              <a:buNone/>
+            </a:pPr>
+            <a:r>
+              <a:rPr lang="en-US" sz="1300" b="1" dirty="0">
+                <a:solidFill>
+                  <a:srgbClr val="2563EB"/>
+                </a:solidFill>
+                <a:latin typeface="Courier New" pitchFamily="34" charset="0"/>
+                <a:ea typeface="Courier New" pitchFamily="34" charset="-122"/>
+                <a:cs typeface="Courier New" pitchFamily="34" charset="-120"/>
+              </a:rPr>
+              <a:t>ds-retrofit</a:t>
+            </a:r>
+            <a:endParaRPr lang="en-US" sz="1300" dirty="0"/>
           </a:p>
         </p:txBody>
       </p:sp>
@@ -8908,34 +9769,34 @@
         </p:nvSpPr>
         <p:spPr>
           <a:xfrm>
-            <a:off x="4535424" y="2788920"/>
-            <a:ext cx="3118104" cy="548640"/>
-          </a:xfrm>
-          <a:prstGeom prst="rect">
-            <a:avLst/>
-          </a:prstGeom>
-          <a:noFill/>
-          <a:ln/>
-        </p:spPr>
-        <p:txBody>
-          <a:bodyPr wrap="square" lIns="0" tIns="0" rIns="0" bIns="0" rtlCol="0" anchor="ctr"/>
-          <a:lstStyle/>
-          <a:p>
-            <a:pPr algn="ctr" indent="0" marL="0">
-              <a:buNone/>
-            </a:pPr>
-            <a:r>
-              <a:rPr lang="en-US" sz="1200" dirty="0">
-                <a:solidFill>
-                  <a:srgbClr val="9DB0CC"/>
-                </a:solidFill>
-                <a:latin typeface="Calibri" pitchFamily="34" charset="0"/>
-                <a:ea typeface="Calibri" pitchFamily="34" charset="-122"/>
-                <a:cs typeface="Calibri" pitchFamily="34" charset="-120"/>
-              </a:rPr>
-              <a:t>public tokens · 131 themable hooks, zero dead</a:t>
-            </a:r>
-            <a:endParaRPr lang="en-US" sz="1200" dirty="0"/>
+            <a:off x="4538472" y="2057400"/>
+            <a:ext cx="3112008" cy="1371600"/>
+          </a:xfrm>
+          <a:prstGeom prst="rect">
+            <a:avLst/>
+          </a:prstGeom>
+          <a:noFill/>
+          <a:ln/>
+        </p:spPr>
+        <p:txBody>
+          <a:bodyPr wrap="square" lIns="0" tIns="0" rIns="0" bIns="0" rtlCol="0" anchor="ctr"/>
+          <a:lstStyle/>
+          <a:p>
+            <a:pPr indent="0" marL="0">
+              <a:buNone/>
+            </a:pPr>
+            <a:r>
+              <a:rPr lang="en-US" sz="1100" dirty="0">
+                <a:solidFill>
+                  <a:srgbClr val="5A6B7E"/>
+                </a:solidFill>
+                <a:latin typeface="Calibri" pitchFamily="34" charset="0"/>
+                <a:ea typeface="Calibri" pitchFamily="34" charset="-122"/>
+                <a:cs typeface="Calibri" pitchFamily="34" charset="-120"/>
+              </a:rPr>
+              <a:t>Their existing system in — CSS vars, Tailwind, React lib — our registries, machine surface, and fabrication gauntlet out. No rewrite.</a:t>
+            </a:r>
+            <a:endParaRPr lang="en-US" sz="1100" dirty="0"/>
           </a:p>
         </p:txBody>
       </p:sp>
@@ -8947,20 +9808,20 @@
         </p:nvSpPr>
         <p:spPr>
           <a:xfrm>
-            <a:off x="8156448" y="1600200"/>
-            <a:ext cx="3483864" cy="1874520"/>
+            <a:off x="8125968" y="1554480"/>
+            <a:ext cx="3514344" cy="2011680"/>
           </a:xfrm>
           <a:prstGeom prst="roundRect">
             <a:avLst>
-              <a:gd name="adj" fmla="val 4878"/>
+              <a:gd name="adj" fmla="val 4545"/>
             </a:avLst>
           </a:prstGeom>
           <a:solidFill>
-            <a:srgbClr val="1B2740"/>
+            <a:srgbClr val="F8FAFC"/>
           </a:solidFill>
           <a:ln w="12700">
             <a:solidFill>
-              <a:srgbClr val="2C3C5E"/>
+              <a:srgbClr val="E2E8F0"/>
             </a:solidFill>
             <a:prstDash val="solid"/>
           </a:ln>
@@ -8974,34 +9835,34 @@
         </p:nvSpPr>
         <p:spPr>
           <a:xfrm>
-            <a:off x="8339328" y="1828800"/>
-            <a:ext cx="3118104" cy="914400"/>
-          </a:xfrm>
-          <a:prstGeom prst="rect">
-            <a:avLst/>
-          </a:prstGeom>
-          <a:noFill/>
-          <a:ln/>
-        </p:spPr>
-        <p:txBody>
-          <a:bodyPr wrap="square" lIns="0" tIns="0" rIns="0" bIns="0" rtlCol="0" anchor="ctr"/>
-          <a:lstStyle/>
-          <a:p>
-            <a:pPr algn="ctr" indent="0" marL="0">
-              <a:buNone/>
-            </a:pPr>
-            <a:r>
-              <a:rPr lang="en-US" sz="4400" b="1" dirty="0">
-                <a:solidFill>
-                  <a:srgbClr val="FFFFFF"/>
-                </a:solidFill>
-                <a:latin typeface="Calibri" pitchFamily="34" charset="0"/>
-                <a:ea typeface="Calibri" pitchFamily="34" charset="-122"/>
-                <a:cs typeface="Calibri" pitchFamily="34" charset="-120"/>
-              </a:rPr>
-              <a:t>97 / 0</a:t>
-            </a:r>
-            <a:endParaRPr lang="en-US" sz="4400" dirty="0"/>
+            <a:off x="8327136" y="1700784"/>
+            <a:ext cx="3112008" cy="320040"/>
+          </a:xfrm>
+          <a:prstGeom prst="rect">
+            <a:avLst/>
+          </a:prstGeom>
+          <a:noFill/>
+          <a:ln/>
+        </p:spPr>
+        <p:txBody>
+          <a:bodyPr wrap="square" lIns="0" tIns="0" rIns="0" bIns="0" rtlCol="0" anchor="ctr"/>
+          <a:lstStyle/>
+          <a:p>
+            <a:pPr indent="0" marL="0">
+              <a:buNone/>
+            </a:pPr>
+            <a:r>
+              <a:rPr lang="en-US" sz="1300" b="1" dirty="0">
+                <a:solidFill>
+                  <a:srgbClr val="2563EB"/>
+                </a:solidFill>
+                <a:latin typeface="Courier New" pitchFamily="34" charset="0"/>
+                <a:ea typeface="Courier New" pitchFamily="34" charset="-122"/>
+                <a:cs typeface="Courier New" pitchFamily="34" charset="-120"/>
+              </a:rPr>
+              <a:t>ds-fleet</a:t>
+            </a:r>
+            <a:endParaRPr lang="en-US" sz="1300" dirty="0"/>
           </a:p>
         </p:txBody>
       </p:sp>
@@ -9013,34 +9874,34 @@
         </p:nvSpPr>
         <p:spPr>
           <a:xfrm>
-            <a:off x="8339328" y="2788920"/>
-            <a:ext cx="3118104" cy="548640"/>
-          </a:xfrm>
-          <a:prstGeom prst="rect">
-            <a:avLst/>
-          </a:prstGeom>
-          <a:noFill/>
-          <a:ln/>
-        </p:spPr>
-        <p:txBody>
-          <a:bodyPr wrap="square" lIns="0" tIns="0" rIns="0" bIns="0" rtlCol="0" anchor="ctr"/>
-          <a:lstStyle/>
-          <a:p>
-            <a:pPr algn="ctr" indent="0" marL="0">
-              <a:buNone/>
-            </a:pPr>
-            <a:r>
-              <a:rPr lang="en-US" sz="1200" dirty="0">
-                <a:solidFill>
-                  <a:srgbClr val="9DB0CC"/>
-                </a:solidFill>
-                <a:latin typeface="Calibri" pitchFamily="34" charset="0"/>
-                <a:ea typeface="Calibri" pitchFamily="34" charset="-122"/>
-                <a:cs typeface="Calibri" pitchFamily="34" charset="-120"/>
-              </a:rPr>
-              <a:t>stories swept by browser axe / violations</a:t>
-            </a:r>
-            <a:endParaRPr lang="en-US" sz="1200" dirty="0"/>
+            <a:off x="8327136" y="2057400"/>
+            <a:ext cx="3112008" cy="1371600"/>
+          </a:xfrm>
+          <a:prstGeom prst="rect">
+            <a:avLst/>
+          </a:prstGeom>
+          <a:noFill/>
+          <a:ln/>
+        </p:spPr>
+        <p:txBody>
+          <a:bodyPr wrap="square" lIns="0" tIns="0" rIns="0" bIns="0" rtlCol="0" anchor="ctr"/>
+          <a:lstStyle/>
+          <a:p>
+            <a:pPr indent="0" marL="0">
+              <a:buNone/>
+            </a:pPr>
+            <a:r>
+              <a:rPr lang="en-US" sz="1100" dirty="0">
+                <a:solidFill>
+                  <a:srgbClr val="5A6B7E"/>
+                </a:solidFill>
+                <a:latin typeface="Calibri" pitchFamily="34" charset="0"/>
+                <a:ea typeface="Calibri" pitchFamily="34" charset="-122"/>
+                <a:cs typeface="Calibri" pitchFamily="34" charset="-120"/>
+              </a:rPr>
+              <a:t>Hallucination rate, first-pass rate, and policy compliance across N repos in one dashboard; policy-as-code breaches block merges.</a:t>
+            </a:r>
+            <a:endParaRPr lang="en-US" sz="1100" dirty="0"/>
           </a:p>
         </p:txBody>
       </p:sp>
@@ -9052,20 +9913,20 @@
         </p:nvSpPr>
         <p:spPr>
           <a:xfrm>
-            <a:off x="548640" y="3749040"/>
-            <a:ext cx="3483864" cy="1874520"/>
+            <a:off x="548640" y="3840480"/>
+            <a:ext cx="3514344" cy="2011680"/>
           </a:xfrm>
           <a:prstGeom prst="roundRect">
             <a:avLst>
-              <a:gd name="adj" fmla="val 4878"/>
+              <a:gd name="adj" fmla="val 4545"/>
             </a:avLst>
           </a:prstGeom>
           <a:solidFill>
-            <a:srgbClr val="1B2740"/>
+            <a:srgbClr val="F8FAFC"/>
           </a:solidFill>
           <a:ln w="12700">
             <a:solidFill>
-              <a:srgbClr val="2C3C5E"/>
+              <a:srgbClr val="E2E8F0"/>
             </a:solidFill>
             <a:prstDash val="solid"/>
           </a:ln>
@@ -9079,34 +9940,34 @@
         </p:nvSpPr>
         <p:spPr>
           <a:xfrm>
-            <a:off x="731520" y="3977640"/>
-            <a:ext cx="3118104" cy="914400"/>
-          </a:xfrm>
-          <a:prstGeom prst="rect">
-            <a:avLst/>
-          </a:prstGeom>
-          <a:noFill/>
-          <a:ln/>
-        </p:spPr>
-        <p:txBody>
-          <a:bodyPr wrap="square" lIns="0" tIns="0" rIns="0" bIns="0" rtlCol="0" anchor="ctr"/>
-          <a:lstStyle/>
-          <a:p>
-            <a:pPr algn="ctr" indent="0" marL="0">
-              <a:buNone/>
-            </a:pPr>
-            <a:r>
-              <a:rPr lang="en-US" sz="4400" b="1" dirty="0">
-                <a:solidFill>
-                  <a:srgbClr val="FFFFFF"/>
-                </a:solidFill>
-                <a:latin typeface="Calibri" pitchFamily="34" charset="0"/>
-                <a:ea typeface="Calibri" pitchFamily="34" charset="-122"/>
-                <a:cs typeface="Calibri" pitchFamily="34" charset="-120"/>
-              </a:rPr>
-              <a:t>21 / 21</a:t>
-            </a:r>
-            <a:endParaRPr lang="en-US" sz="4400" dirty="0"/>
+            <a:off x="749808" y="3986784"/>
+            <a:ext cx="3112008" cy="320040"/>
+          </a:xfrm>
+          <a:prstGeom prst="rect">
+            <a:avLst/>
+          </a:prstGeom>
+          <a:noFill/>
+          <a:ln/>
+        </p:spPr>
+        <p:txBody>
+          <a:bodyPr wrap="square" lIns="0" tIns="0" rIns="0" bIns="0" rtlCol="0" anchor="ctr"/>
+          <a:lstStyle/>
+          <a:p>
+            <a:pPr indent="0" marL="0">
+              <a:buNone/>
+            </a:pPr>
+            <a:r>
+              <a:rPr lang="en-US" sz="1300" b="1" dirty="0">
+                <a:solidFill>
+                  <a:srgbClr val="2563EB"/>
+                </a:solidFill>
+                <a:latin typeface="Courier New" pitchFamily="34" charset="0"/>
+                <a:ea typeface="Courier New" pitchFamily="34" charset="-122"/>
+                <a:cs typeface="Courier New" pitchFamily="34" charset="-120"/>
+              </a:rPr>
+              <a:t>@ds/genui</a:t>
+            </a:r>
+            <a:endParaRPr lang="en-US" sz="1300" dirty="0"/>
           </a:p>
         </p:txBody>
       </p:sp>
@@ -9118,34 +9979,34 @@
         </p:nvSpPr>
         <p:spPr>
           <a:xfrm>
-            <a:off x="731520" y="4937760"/>
-            <a:ext cx="3118104" cy="548640"/>
-          </a:xfrm>
-          <a:prstGeom prst="rect">
-            <a:avLst/>
-          </a:prstGeom>
-          <a:noFill/>
-          <a:ln/>
-        </p:spPr>
-        <p:txBody>
-          <a:bodyPr wrap="square" lIns="0" tIns="0" rIns="0" bIns="0" rtlCol="0" anchor="ctr"/>
-          <a:lstStyle/>
-          <a:p>
-            <a:pPr algn="ctr" indent="0" marL="0">
-              <a:buNone/>
-            </a:pPr>
-            <a:r>
-              <a:rPr lang="en-US" sz="1200" dirty="0">
-                <a:solidFill>
-                  <a:srgbClr val="9DB0CC"/>
-                </a:solidFill>
-                <a:latin typeface="Calibri" pitchFamily="34" charset="0"/>
-                <a:ea typeface="Calibri" pitchFamily="34" charset="-122"/>
-                <a:cs typeface="Calibri" pitchFamily="34" charset="-120"/>
-              </a:rPr>
-              <a:t>evals passing · critical at 1.0</a:t>
-            </a:r>
-            <a:endParaRPr lang="en-US" sz="1200" dirty="0"/>
+            <a:off x="749808" y="4343400"/>
+            <a:ext cx="3112008" cy="1371600"/>
+          </a:xfrm>
+          <a:prstGeom prst="rect">
+            <a:avLst/>
+          </a:prstGeom>
+          <a:noFill/>
+          <a:ln/>
+        </p:spPr>
+        <p:txBody>
+          <a:bodyPr wrap="square" lIns="0" tIns="0" rIns="0" bIns="0" rtlCol="0" anchor="ctr"/>
+          <a:lstStyle/>
+          <a:p>
+            <a:pPr indent="0" marL="0">
+              <a:buNone/>
+            </a:pPr>
+            <a:r>
+              <a:rPr lang="en-US" sz="1100" dirty="0">
+                <a:solidFill>
+                  <a:srgbClr val="5A6B7E"/>
+                </a:solidFill>
+                <a:latin typeface="Calibri" pitchFamily="34" charset="0"/>
+                <a:ea typeface="Calibri" pitchFamily="34" charset="-122"/>
+                <a:cs typeface="Calibri" pitchFamily="34" charset="-120"/>
+              </a:rPr>
+              <a:t>Safe generative UI at runtime: agents emit a wire format that can only compose registry components. 51-case fuzz: all injections inert.</a:t>
+            </a:r>
+            <a:endParaRPr lang="en-US" sz="1100" dirty="0"/>
           </a:p>
         </p:txBody>
       </p:sp>
@@ -9157,20 +10018,20 @@
         </p:nvSpPr>
         <p:spPr>
           <a:xfrm>
-            <a:off x="4352544" y="3749040"/>
-            <a:ext cx="3483864" cy="1874520"/>
+            <a:off x="4337304" y="3840480"/>
+            <a:ext cx="3514344" cy="2011680"/>
           </a:xfrm>
           <a:prstGeom prst="roundRect">
             <a:avLst>
-              <a:gd name="adj" fmla="val 4878"/>
+              <a:gd name="adj" fmla="val 4545"/>
             </a:avLst>
           </a:prstGeom>
           <a:solidFill>
-            <a:srgbClr val="1B2740"/>
+            <a:srgbClr val="F8FAFC"/>
           </a:solidFill>
           <a:ln w="12700">
             <a:solidFill>
-              <a:srgbClr val="2C3C5E"/>
+              <a:srgbClr val="E2E8F0"/>
             </a:solidFill>
             <a:prstDash val="solid"/>
           </a:ln>
@@ -9184,34 +10045,34 @@
         </p:nvSpPr>
         <p:spPr>
           <a:xfrm>
-            <a:off x="4535424" y="3977640"/>
-            <a:ext cx="3118104" cy="914400"/>
-          </a:xfrm>
-          <a:prstGeom prst="rect">
-            <a:avLst/>
-          </a:prstGeom>
-          <a:noFill/>
-          <a:ln/>
-        </p:spPr>
-        <p:txBody>
-          <a:bodyPr wrap="square" lIns="0" tIns="0" rIns="0" bIns="0" rtlCol="0" anchor="ctr"/>
-          <a:lstStyle/>
-          <a:p>
-            <a:pPr algn="ctr" indent="0" marL="0">
-              <a:buNone/>
-            </a:pPr>
-            <a:r>
-              <a:rPr lang="en-US" sz="4400" b="1" dirty="0">
-                <a:solidFill>
-                  <a:srgbClr val="FFFFFF"/>
-                </a:solidFill>
-                <a:latin typeface="Calibri" pitchFamily="34" charset="0"/>
-                <a:ea typeface="Calibri" pitchFamily="34" charset="-122"/>
-                <a:cs typeface="Calibri" pitchFamily="34" charset="-120"/>
-              </a:rPr>
-              <a:t>5 / 5</a:t>
-            </a:r>
-            <a:endParaRPr lang="en-US" sz="4400" dirty="0"/>
+            <a:off x="4538472" y="3986784"/>
+            <a:ext cx="3112008" cy="320040"/>
+          </a:xfrm>
+          <a:prstGeom prst="rect">
+            <a:avLst/>
+          </a:prstGeom>
+          <a:noFill/>
+          <a:ln/>
+        </p:spPr>
+        <p:txBody>
+          <a:bodyPr wrap="square" lIns="0" tIns="0" rIns="0" bIns="0" rtlCol="0" anchor="ctr"/>
+          <a:lstStyle/>
+          <a:p>
+            <a:pPr indent="0" marL="0">
+              <a:buNone/>
+            </a:pPr>
+            <a:r>
+              <a:rPr lang="en-US" sz="1300" b="1" dirty="0">
+                <a:solidFill>
+                  <a:srgbClr val="2563EB"/>
+                </a:solidFill>
+                <a:latin typeface="Courier New" pitchFamily="34" charset="0"/>
+                <a:ea typeface="Courier New" pitchFamily="34" charset="-122"/>
+                <a:cs typeface="Courier New" pitchFamily="34" charset="-120"/>
+              </a:rPr>
+              <a:t>@ds/wc + RN</a:t>
+            </a:r>
+            <a:endParaRPr lang="en-US" sz="1300" dirty="0"/>
           </a:p>
         </p:txBody>
       </p:sp>
@@ -9223,34 +10084,34 @@
         </p:nvSpPr>
         <p:spPr>
           <a:xfrm>
-            <a:off x="4535424" y="4937760"/>
-            <a:ext cx="3118104" cy="548640"/>
-          </a:xfrm>
-          <a:prstGeom prst="rect">
-            <a:avLst/>
-          </a:prstGeom>
-          <a:noFill/>
-          <a:ln/>
-        </p:spPr>
-        <p:txBody>
-          <a:bodyPr wrap="square" lIns="0" tIns="0" rIns="0" bIns="0" rtlCol="0" anchor="ctr"/>
-          <a:lstStyle/>
-          <a:p>
-            <a:pPr algn="ctr" indent="0" marL="0">
-              <a:buNone/>
-            </a:pPr>
-            <a:r>
-              <a:rPr lang="en-US" sz="1200" dirty="0">
-                <a:solidFill>
-                  <a:srgbClr val="9DB0CC"/>
-                </a:solidFill>
-                <a:latin typeface="Calibri" pitchFamily="34" charset="0"/>
-                <a:ea typeface="Calibri" pitchFamily="34" charset="-122"/>
-                <a:cs typeface="Calibri" pitchFamily="34" charset="-120"/>
-              </a:rPr>
-              <a:t>gauntlet steps green, no LLM in the gate</a:t>
-            </a:r>
-            <a:endParaRPr lang="en-US" sz="1200" dirty="0"/>
+            <a:off x="4538472" y="4343400"/>
+            <a:ext cx="3112008" cy="1371600"/>
+          </a:xfrm>
+          <a:prstGeom prst="rect">
+            <a:avLst/>
+          </a:prstGeom>
+          <a:noFill/>
+          <a:ln/>
+        </p:spPr>
+        <p:txBody>
+          <a:bodyPr wrap="square" lIns="0" tIns="0" rIns="0" bIns="0" rtlCol="0" anchor="ctr"/>
+          <a:lstStyle/>
+          <a:p>
+            <a:pPr indent="0" marL="0">
+              <a:buNone/>
+            </a:pPr>
+            <a:r>
+              <a:rPr lang="en-US" sz="1100" dirty="0">
+                <a:solidFill>
+                  <a:srgbClr val="5A6B7E"/>
+                </a:solidFill>
+                <a:latin typeface="Calibri" pitchFamily="34" charset="0"/>
+                <a:ea typeface="Calibri" pitchFamily="34" charset="-122"/>
+                <a:cs typeface="Calibri" pitchFamily="34" charset="-120"/>
+              </a:rPr>
+              <a:t>Same token graph, new render targets — Shadow-DOM CSS, React Native styles, a registry-listed web component.</a:t>
+            </a:r>
+            <a:endParaRPr lang="en-US" sz="1100" dirty="0"/>
           </a:p>
         </p:txBody>
       </p:sp>
@@ -9262,20 +10123,20 @@
         </p:nvSpPr>
         <p:spPr>
           <a:xfrm>
-            <a:off x="8156448" y="3749040"/>
-            <a:ext cx="3483864" cy="1874520"/>
+            <a:off x="8125968" y="3840480"/>
+            <a:ext cx="3514344" cy="2011680"/>
           </a:xfrm>
           <a:prstGeom prst="roundRect">
             <a:avLst>
-              <a:gd name="adj" fmla="val 4878"/>
+              <a:gd name="adj" fmla="val 4545"/>
             </a:avLst>
           </a:prstGeom>
           <a:solidFill>
-            <a:srgbClr val="1B2740"/>
+            <a:srgbClr val="F8FAFC"/>
           </a:solidFill>
           <a:ln w="12700">
             <a:solidFill>
-              <a:srgbClr val="2C3C5E"/>
+              <a:srgbClr val="E2E8F0"/>
             </a:solidFill>
             <a:prstDash val="solid"/>
           </a:ln>
@@ -9289,34 +10150,34 @@
         </p:nvSpPr>
         <p:spPr>
           <a:xfrm>
-            <a:off x="8339328" y="3977640"/>
-            <a:ext cx="3118104" cy="914400"/>
-          </a:xfrm>
-          <a:prstGeom prst="rect">
-            <a:avLst/>
-          </a:prstGeom>
-          <a:noFill/>
-          <a:ln/>
-        </p:spPr>
-        <p:txBody>
-          <a:bodyPr wrap="square" lIns="0" tIns="0" rIns="0" bIns="0" rtlCol="0" anchor="ctr"/>
-          <a:lstStyle/>
-          <a:p>
-            <a:pPr algn="ctr" indent="0" marL="0">
-              <a:buNone/>
-            </a:pPr>
-            <a:r>
-              <a:rPr lang="en-US" sz="4400" b="1" dirty="0">
-                <a:solidFill>
-                  <a:srgbClr val="6FD8A8"/>
-                </a:solidFill>
-                <a:latin typeface="Calibri" pitchFamily="34" charset="0"/>
-                <a:ea typeface="Calibri" pitchFamily="34" charset="-122"/>
-                <a:cs typeface="Calibri" pitchFamily="34" charset="-120"/>
-              </a:rPr>
-              <a:t>260 ms</a:t>
-            </a:r>
-            <a:endParaRPr lang="en-US" sz="4400" dirty="0"/>
+            <a:off x="8327136" y="3986784"/>
+            <a:ext cx="3112008" cy="320040"/>
+          </a:xfrm>
+          <a:prstGeom prst="rect">
+            <a:avLst/>
+          </a:prstGeom>
+          <a:noFill/>
+          <a:ln/>
+        </p:spPr>
+        <p:txBody>
+          <a:bodyPr wrap="square" lIns="0" tIns="0" rIns="0" bIns="0" rtlCol="0" anchor="ctr"/>
+          <a:lstStyle/>
+          <a:p>
+            <a:pPr indent="0" marL="0">
+              <a:buNone/>
+            </a:pPr>
+            <a:r>
+              <a:rPr lang="en-US" sz="1300" b="1" dirty="0">
+                <a:solidFill>
+                  <a:srgbClr val="2563EB"/>
+                </a:solidFill>
+                <a:latin typeface="Courier New" pitchFamily="34" charset="0"/>
+                <a:ea typeface="Courier New" pitchFamily="34" charset="-122"/>
+                <a:cs typeface="Courier New" pitchFamily="34" charset="-120"/>
+              </a:rPr>
+              <a:t>evidence pack</a:t>
+            </a:r>
+            <a:endParaRPr lang="en-US" sz="1300" dirty="0"/>
           </a:p>
         </p:txBody>
       </p:sp>
@@ -9328,34 +10189,34 @@
         </p:nvSpPr>
         <p:spPr>
           <a:xfrm>
-            <a:off x="8339328" y="4937760"/>
-            <a:ext cx="3118104" cy="548640"/>
-          </a:xfrm>
-          <a:prstGeom prst="rect">
-            <a:avLst/>
-          </a:prstGeom>
-          <a:noFill/>
-          <a:ln/>
-        </p:spPr>
-        <p:txBody>
-          <a:bodyPr wrap="square" lIns="0" tIns="0" rIns="0" bIns="0" rtlCol="0" anchor="ctr"/>
-          <a:lstStyle/>
-          <a:p>
-            <a:pPr algn="ctr" indent="0" marL="0">
-              <a:buNone/>
-            </a:pPr>
-            <a:r>
-              <a:rPr lang="en-US" sz="1200" dirty="0">
-                <a:solidFill>
-                  <a:srgbClr val="9DB0CC"/>
-                </a:solidFill>
-                <a:latin typeface="Calibri" pitchFamily="34" charset="0"/>
-                <a:ea typeface="Calibri" pitchFamily="34" charset="-122"/>
-                <a:cs typeface="Calibri" pitchFamily="34" charset="-120"/>
-              </a:rPr>
-              <a:t>full customer re-theme, AI artifacts included</a:t>
-            </a:r>
-            <a:endParaRPr lang="en-US" sz="1200" dirty="0"/>
+            <a:off x="8327136" y="4343400"/>
+            <a:ext cx="3112008" cy="1371600"/>
+          </a:xfrm>
+          <a:prstGeom prst="rect">
+            <a:avLst/>
+          </a:prstGeom>
+          <a:noFill/>
+          <a:ln/>
+        </p:spPr>
+        <p:txBody>
+          <a:bodyPr wrap="square" lIns="0" tIns="0" rIns="0" bIns="0" rtlCol="0" anchor="ctr"/>
+          <a:lstStyle/>
+          <a:p>
+            <a:pPr indent="0" marL="0">
+              <a:buNone/>
+            </a:pPr>
+            <a:r>
+              <a:rPr lang="en-US" sz="1100" dirty="0">
+                <a:solidFill>
+                  <a:srgbClr val="5A6B7E"/>
+                </a:solidFill>
+                <a:latin typeface="Calibri" pitchFamily="34" charset="0"/>
+                <a:ea typeface="Calibri" pitchFamily="34" charset="-122"/>
+                <a:cs typeface="Calibri" pitchFamily="34" charset="-120"/>
+              </a:rPr>
+              <a:t>One command → auditor bundle: WCAG, provenance, dependencies. A broken system cannot produce passing evidence.</a:t>
+            </a:r>
+            <a:endParaRPr lang="en-US" sz="1100" dirty="0"/>
           </a:p>
         </p:txBody>
       </p:sp>
@@ -9368,33 +10229,33 @@
         <p:spPr>
           <a:xfrm>
             <a:off x="548640" y="6035040"/>
-            <a:ext cx="11091672" cy="411480"/>
-          </a:xfrm>
-          <a:prstGeom prst="rect">
-            <a:avLst/>
-          </a:prstGeom>
-          <a:noFill/>
-          <a:ln/>
-        </p:spPr>
-        <p:txBody>
-          <a:bodyPr wrap="square" lIns="0" tIns="0" rIns="0" bIns="0" rtlCol="0" anchor="ctr"/>
-          <a:lstStyle/>
-          <a:p>
-            <a:pPr algn="ctr" indent="0" marL="0">
-              <a:buNone/>
-            </a:pPr>
-            <a:r>
-              <a:rPr lang="en-US" sz="1500" b="1" dirty="0">
-                <a:solidFill>
-                  <a:srgbClr val="7EE0A3"/>
-                </a:solidFill>
-                <a:latin typeface="Calibri" pitchFamily="34" charset="0"/>
-                <a:ea typeface="Calibri" pitchFamily="34" charset="-122"/>
-                <a:cs typeface="Calibri" pitchFamily="34" charset="-120"/>
-              </a:rPr>
-              <a:t>Hallucination rate across every acceptance test and the build itself:  zero.</a:t>
-            </a:r>
-            <a:endParaRPr lang="en-US" sz="1500" dirty="0"/>
+            <a:ext cx="11091672" cy="457200"/>
+          </a:xfrm>
+          <a:prstGeom prst="rect">
+            <a:avLst/>
+          </a:prstGeom>
+          <a:noFill/>
+          <a:ln/>
+        </p:spPr>
+        <p:txBody>
+          <a:bodyPr wrap="square" lIns="0" tIns="0" rIns="0" bIns="0" rtlCol="0" anchor="ctr"/>
+          <a:lstStyle/>
+          <a:p>
+            <a:pPr indent="0" marL="0">
+              <a:buNone/>
+            </a:pPr>
+            <a:r>
+              <a:rPr lang="en-US" sz="1250" i="1" dirty="0">
+                <a:solidFill>
+                  <a:srgbClr val="1E3A8A"/>
+                </a:solidFill>
+                <a:latin typeface="Calibri" pitchFamily="34" charset="0"/>
+                <a:ea typeface="Calibri" pitchFamily="34" charset="-122"/>
+                <a:cs typeface="Calibri" pitchFamily="34" charset="-120"/>
+              </a:rPr>
+              <a:t>Every capability runs locally with zero credentials — and the gauntlet now governs this repo itself: policy-as-code is merge-blocking here, 6/6 green.</a:t>
+            </a:r>
+            <a:endParaRPr lang="en-US" sz="1250" dirty="0"/>
           </a:p>
         </p:txBody>
       </p:sp>

</xml_diff>

<commit_message>
One measured number everywhere: 1,013 tests across eleven packages
Reviewer caught README (662/six) and deck (~1,300/nine) disagreeing; both were
stale or estimated. Replaced with the measured total on all three surfaces.

Co-Authored-By: Claude Fable 5 <noreply@anthropic.com>
</commit_message>
<xml_diff>
--- a/docs/AIR-DS-overview.pptx
+++ b/docs/AIR-DS-overview.pptx
@@ -2378,7 +2378,7 @@
                 <a:ea typeface="Calibri" pitchFamily="34" charset="-122"/>
                 <a:cs typeface="Calibri" pitchFamily="34" charset="-120"/>
               </a:rPr>
-              <a:t>~1,300</a:t>
+              <a:t>1,013</a:t>
             </a:r>
             <a:endParaRPr lang="en-US" sz="4400" dirty="0"/>
           </a:p>
@@ -2417,7 +2417,7 @@
                 <a:ea typeface="Calibri" pitchFamily="34" charset="-122"/>
                 <a:cs typeface="Calibri" pitchFamily="34" charset="-120"/>
               </a:rPr>
-              <a:t>tests across nine packages</a:t>
+              <a:t>tests across eleven packages</a:t>
             </a:r>
             <a:endParaRPr lang="en-US" sz="1200" dirty="0"/>
           </a:p>

</xml_diff>